<commit_message>
Local updates (plots, notebooks, deletions)
</commit_message>
<xml_diff>
--- a/data/ML_presentation.pptx
+++ b/data/ML_presentation.pptx
@@ -211,7 +211,7 @@
           <a:p>
             <a:fld id="{6F0177B5-648F-B443-BBB4-B6E3AD4331B7}" type="datetimeFigureOut">
               <a:rPr lang="en-US" smtClean="0"/>
-              <a:t>10/9/25</a:t>
+              <a:t>12/7/25</a:t>
             </a:fld>
             <a:endParaRPr lang="en-US"/>
           </a:p>
@@ -2031,7 +2031,7 @@
           <a:p>
             <a:fld id="{56BFE181-1418-7048-B8F0-0705399AA7B0}" type="datetimeFigureOut">
               <a:rPr lang="en-US" smtClean="0"/>
-              <a:t>10/9/25</a:t>
+              <a:t>12/7/25</a:t>
             </a:fld>
             <a:endParaRPr lang="en-US"/>
           </a:p>
@@ -2229,7 +2229,7 @@
           <a:p>
             <a:fld id="{56BFE181-1418-7048-B8F0-0705399AA7B0}" type="datetimeFigureOut">
               <a:rPr lang="en-US" smtClean="0"/>
-              <a:t>10/9/25</a:t>
+              <a:t>12/7/25</a:t>
             </a:fld>
             <a:endParaRPr lang="en-US"/>
           </a:p>
@@ -2437,7 +2437,7 @@
           <a:p>
             <a:fld id="{56BFE181-1418-7048-B8F0-0705399AA7B0}" type="datetimeFigureOut">
               <a:rPr lang="en-US" smtClean="0"/>
-              <a:t>10/9/25</a:t>
+              <a:t>12/7/25</a:t>
             </a:fld>
             <a:endParaRPr lang="en-US"/>
           </a:p>
@@ -2635,7 +2635,7 @@
           <a:p>
             <a:fld id="{56BFE181-1418-7048-B8F0-0705399AA7B0}" type="datetimeFigureOut">
               <a:rPr lang="en-US" smtClean="0"/>
-              <a:t>10/9/25</a:t>
+              <a:t>12/7/25</a:t>
             </a:fld>
             <a:endParaRPr lang="en-US"/>
           </a:p>
@@ -2910,7 +2910,7 @@
           <a:p>
             <a:fld id="{56BFE181-1418-7048-B8F0-0705399AA7B0}" type="datetimeFigureOut">
               <a:rPr lang="en-US" smtClean="0"/>
-              <a:t>10/9/25</a:t>
+              <a:t>12/7/25</a:t>
             </a:fld>
             <a:endParaRPr lang="en-US"/>
           </a:p>
@@ -3175,7 +3175,7 @@
           <a:p>
             <a:fld id="{56BFE181-1418-7048-B8F0-0705399AA7B0}" type="datetimeFigureOut">
               <a:rPr lang="en-US" smtClean="0"/>
-              <a:t>10/9/25</a:t>
+              <a:t>12/7/25</a:t>
             </a:fld>
             <a:endParaRPr lang="en-US"/>
           </a:p>
@@ -3587,7 +3587,7 @@
           <a:p>
             <a:fld id="{56BFE181-1418-7048-B8F0-0705399AA7B0}" type="datetimeFigureOut">
               <a:rPr lang="en-US" smtClean="0"/>
-              <a:t>10/9/25</a:t>
+              <a:t>12/7/25</a:t>
             </a:fld>
             <a:endParaRPr lang="en-US"/>
           </a:p>
@@ -3728,7 +3728,7 @@
           <a:p>
             <a:fld id="{56BFE181-1418-7048-B8F0-0705399AA7B0}" type="datetimeFigureOut">
               <a:rPr lang="en-US" smtClean="0"/>
-              <a:t>10/9/25</a:t>
+              <a:t>12/7/25</a:t>
             </a:fld>
             <a:endParaRPr lang="en-US"/>
           </a:p>
@@ -3841,7 +3841,7 @@
           <a:p>
             <a:fld id="{56BFE181-1418-7048-B8F0-0705399AA7B0}" type="datetimeFigureOut">
               <a:rPr lang="en-US" smtClean="0"/>
-              <a:t>10/9/25</a:t>
+              <a:t>12/7/25</a:t>
             </a:fld>
             <a:endParaRPr lang="en-US"/>
           </a:p>
@@ -4152,7 +4152,7 @@
           <a:p>
             <a:fld id="{56BFE181-1418-7048-B8F0-0705399AA7B0}" type="datetimeFigureOut">
               <a:rPr lang="en-US" smtClean="0"/>
-              <a:t>10/9/25</a:t>
+              <a:t>12/7/25</a:t>
             </a:fld>
             <a:endParaRPr lang="en-US"/>
           </a:p>
@@ -4440,7 +4440,7 @@
           <a:p>
             <a:fld id="{56BFE181-1418-7048-B8F0-0705399AA7B0}" type="datetimeFigureOut">
               <a:rPr lang="en-US" smtClean="0"/>
-              <a:t>10/9/25</a:t>
+              <a:t>12/7/25</a:t>
             </a:fld>
             <a:endParaRPr lang="en-US"/>
           </a:p>
@@ -4681,7 +4681,7 @@
           <a:p>
             <a:fld id="{56BFE181-1418-7048-B8F0-0705399AA7B0}" type="datetimeFigureOut">
               <a:rPr lang="en-US" smtClean="0"/>
-              <a:t>10/9/25</a:t>
+              <a:t>12/7/25</a:t>
             </a:fld>
             <a:endParaRPr lang="en-US"/>
           </a:p>

</xml_diff>